<commit_message>
added a circle option
</commit_message>
<xml_diff>
--- a/Project Milestone.pptx
+++ b/Project Milestone.pptx
@@ -4,6 +4,9 @@
   <p:sldMasterIdLst>
     <p:sldMasterId id="2147483678" r:id="rId1"/>
   </p:sldMasterIdLst>
+  <p:notesMasterIdLst>
+    <p:notesMasterId r:id="rId9"/>
+  </p:notesMasterIdLst>
   <p:sldIdLst>
     <p:sldId id="256" r:id="rId2"/>
     <p:sldId id="258" r:id="rId3"/>
@@ -118,6 +121,1342 @@
 </p:presentation>
 </file>
 
+<file path=ppt/notesMasters/notesMaster1.xml><?xml version="1.0" encoding="utf-8"?>
+<p:notesMaster xmlns:a="http://schemas.openxmlformats.org/drawingml/2006/main" xmlns:r="http://schemas.openxmlformats.org/officeDocument/2006/relationships" xmlns:p="http://schemas.openxmlformats.org/presentationml/2006/main">
+  <p:cSld>
+    <p:bg>
+      <p:bgRef idx="1001">
+        <a:schemeClr val="bg1"/>
+      </p:bgRef>
+    </p:bg>
+    <p:spTree>
+      <p:nvGrpSpPr>
+        <p:cNvPr id="1" name=""/>
+        <p:cNvGrpSpPr/>
+        <p:nvPr/>
+      </p:nvGrpSpPr>
+      <p:grpSpPr>
+        <a:xfrm>
+          <a:off x="0" y="0"/>
+          <a:ext cx="0" cy="0"/>
+          <a:chOff x="0" y="0"/>
+          <a:chExt cx="0" cy="0"/>
+        </a:xfrm>
+      </p:grpSpPr>
+      <p:sp>
+        <p:nvSpPr>
+          <p:cNvPr id="2" name="Header Placeholder 1"/>
+          <p:cNvSpPr>
+            <a:spLocks noGrp="1"/>
+          </p:cNvSpPr>
+          <p:nvPr>
+            <p:ph type="hdr" sz="quarter"/>
+          </p:nvPr>
+        </p:nvSpPr>
+        <p:spPr>
+          <a:xfrm>
+            <a:off x="0" y="0"/>
+            <a:ext cx="2971800" cy="458788"/>
+          </a:xfrm>
+          <a:prstGeom prst="rect">
+            <a:avLst/>
+          </a:prstGeom>
+        </p:spPr>
+        <p:txBody>
+          <a:bodyPr vert="horz" lIns="91440" tIns="45720" rIns="91440" bIns="45720" rtlCol="0"/>
+          <a:lstStyle>
+            <a:lvl1pPr algn="l">
+              <a:defRPr sz="1200"/>
+            </a:lvl1pPr>
+          </a:lstStyle>
+          <a:p>
+            <a:endParaRPr lang="en-US"/>
+          </a:p>
+        </p:txBody>
+      </p:sp>
+      <p:sp>
+        <p:nvSpPr>
+          <p:cNvPr id="3" name="Date Placeholder 2"/>
+          <p:cNvSpPr>
+            <a:spLocks noGrp="1"/>
+          </p:cNvSpPr>
+          <p:nvPr>
+            <p:ph type="dt" idx="1"/>
+          </p:nvPr>
+        </p:nvSpPr>
+        <p:spPr>
+          <a:xfrm>
+            <a:off x="3884613" y="0"/>
+            <a:ext cx="2971800" cy="458788"/>
+          </a:xfrm>
+          <a:prstGeom prst="rect">
+            <a:avLst/>
+          </a:prstGeom>
+        </p:spPr>
+        <p:txBody>
+          <a:bodyPr vert="horz" lIns="91440" tIns="45720" rIns="91440" bIns="45720" rtlCol="0"/>
+          <a:lstStyle>
+            <a:lvl1pPr algn="r">
+              <a:defRPr sz="1200"/>
+            </a:lvl1pPr>
+          </a:lstStyle>
+          <a:p>
+            <a:fld id="{417827F0-7C17-443D-8666-A4529C210E5F}" type="datetimeFigureOut">
+              <a:rPr lang="en-US" smtClean="0"/>
+              <a:t>5/21/2026</a:t>
+            </a:fld>
+            <a:endParaRPr lang="en-US"/>
+          </a:p>
+        </p:txBody>
+      </p:sp>
+      <p:sp>
+        <p:nvSpPr>
+          <p:cNvPr id="4" name="Slide Image Placeholder 3"/>
+          <p:cNvSpPr>
+            <a:spLocks noGrp="1" noRot="1" noChangeAspect="1"/>
+          </p:cNvSpPr>
+          <p:nvPr>
+            <p:ph type="sldImg" idx="2"/>
+          </p:nvPr>
+        </p:nvSpPr>
+        <p:spPr>
+          <a:xfrm>
+            <a:off x="685800" y="1143000"/>
+            <a:ext cx="5486400" cy="3086100"/>
+          </a:xfrm>
+          <a:prstGeom prst="rect">
+            <a:avLst/>
+          </a:prstGeom>
+          <a:noFill/>
+          <a:ln w="12700">
+            <a:solidFill>
+              <a:prstClr val="black"/>
+            </a:solidFill>
+          </a:ln>
+        </p:spPr>
+        <p:txBody>
+          <a:bodyPr vert="horz" lIns="91440" tIns="45720" rIns="91440" bIns="45720" rtlCol="0" anchor="ctr"/>
+          <a:lstStyle/>
+          <a:p>
+            <a:endParaRPr lang="en-US"/>
+          </a:p>
+        </p:txBody>
+      </p:sp>
+      <p:sp>
+        <p:nvSpPr>
+          <p:cNvPr id="5" name="Notes Placeholder 4"/>
+          <p:cNvSpPr>
+            <a:spLocks noGrp="1"/>
+          </p:cNvSpPr>
+          <p:nvPr>
+            <p:ph type="body" sz="quarter" idx="3"/>
+          </p:nvPr>
+        </p:nvSpPr>
+        <p:spPr>
+          <a:xfrm>
+            <a:off x="685800" y="4400550"/>
+            <a:ext cx="5486400" cy="3600450"/>
+          </a:xfrm>
+          <a:prstGeom prst="rect">
+            <a:avLst/>
+          </a:prstGeom>
+        </p:spPr>
+        <p:txBody>
+          <a:bodyPr vert="horz" lIns="91440" tIns="45720" rIns="91440" bIns="45720" rtlCol="0"/>
+          <a:lstStyle/>
+          <a:p>
+            <a:pPr lvl="0"/>
+            <a:r>
+              <a:rPr lang="en-US"/>
+              <a:t>Click to edit Master text styles</a:t>
+            </a:r>
+          </a:p>
+          <a:p>
+            <a:pPr lvl="1"/>
+            <a:r>
+              <a:rPr lang="en-US"/>
+              <a:t>Second level</a:t>
+            </a:r>
+          </a:p>
+          <a:p>
+            <a:pPr lvl="2"/>
+            <a:r>
+              <a:rPr lang="en-US"/>
+              <a:t>Third level</a:t>
+            </a:r>
+          </a:p>
+          <a:p>
+            <a:pPr lvl="3"/>
+            <a:r>
+              <a:rPr lang="en-US"/>
+              <a:t>Fourth level</a:t>
+            </a:r>
+          </a:p>
+          <a:p>
+            <a:pPr lvl="4"/>
+            <a:r>
+              <a:rPr lang="en-US"/>
+              <a:t>Fifth level</a:t>
+            </a:r>
+          </a:p>
+        </p:txBody>
+      </p:sp>
+      <p:sp>
+        <p:nvSpPr>
+          <p:cNvPr id="6" name="Footer Placeholder 5"/>
+          <p:cNvSpPr>
+            <a:spLocks noGrp="1"/>
+          </p:cNvSpPr>
+          <p:nvPr>
+            <p:ph type="ftr" sz="quarter" idx="4"/>
+          </p:nvPr>
+        </p:nvSpPr>
+        <p:spPr>
+          <a:xfrm>
+            <a:off x="0" y="8685213"/>
+            <a:ext cx="2971800" cy="458787"/>
+          </a:xfrm>
+          <a:prstGeom prst="rect">
+            <a:avLst/>
+          </a:prstGeom>
+        </p:spPr>
+        <p:txBody>
+          <a:bodyPr vert="horz" lIns="91440" tIns="45720" rIns="91440" bIns="45720" rtlCol="0" anchor="b"/>
+          <a:lstStyle>
+            <a:lvl1pPr algn="l">
+              <a:defRPr sz="1200"/>
+            </a:lvl1pPr>
+          </a:lstStyle>
+          <a:p>
+            <a:endParaRPr lang="en-US"/>
+          </a:p>
+        </p:txBody>
+      </p:sp>
+      <p:sp>
+        <p:nvSpPr>
+          <p:cNvPr id="7" name="Slide Number Placeholder 6"/>
+          <p:cNvSpPr>
+            <a:spLocks noGrp="1"/>
+          </p:cNvSpPr>
+          <p:nvPr>
+            <p:ph type="sldNum" sz="quarter" idx="5"/>
+          </p:nvPr>
+        </p:nvSpPr>
+        <p:spPr>
+          <a:xfrm>
+            <a:off x="3884613" y="8685213"/>
+            <a:ext cx="2971800" cy="458787"/>
+          </a:xfrm>
+          <a:prstGeom prst="rect">
+            <a:avLst/>
+          </a:prstGeom>
+        </p:spPr>
+        <p:txBody>
+          <a:bodyPr vert="horz" lIns="91440" tIns="45720" rIns="91440" bIns="45720" rtlCol="0" anchor="b"/>
+          <a:lstStyle>
+            <a:lvl1pPr algn="r">
+              <a:defRPr sz="1200"/>
+            </a:lvl1pPr>
+          </a:lstStyle>
+          <a:p>
+            <a:fld id="{029D3D77-4AE1-4A9F-B764-8C1063FEDE9D}" type="slidenum">
+              <a:rPr lang="en-US" smtClean="0"/>
+              <a:t>‹#›</a:t>
+            </a:fld>
+            <a:endParaRPr lang="en-US"/>
+          </a:p>
+        </p:txBody>
+      </p:sp>
+    </p:spTree>
+    <p:extLst>
+      <p:ext uri="{BB962C8B-B14F-4D97-AF65-F5344CB8AC3E}">
+        <p14:creationId xmlns:p14="http://schemas.microsoft.com/office/powerpoint/2010/main" val="3755038224"/>
+      </p:ext>
+    </p:extLst>
+  </p:cSld>
+  <p:clrMap bg1="lt1" tx1="dk1" bg2="lt2" tx2="dk2" accent1="accent1" accent2="accent2" accent3="accent3" accent4="accent4" accent5="accent5" accent6="accent6" hlink="hlink" folHlink="folHlink"/>
+  <p:notesStyle>
+    <a:lvl1pPr marL="0" algn="l" defTabSz="914400" rtl="0" eaLnBrk="1" latinLnBrk="0" hangingPunct="1">
+      <a:defRPr sz="1200" kern="1200">
+        <a:solidFill>
+          <a:schemeClr val="tx1"/>
+        </a:solidFill>
+        <a:latin typeface="+mn-lt"/>
+        <a:ea typeface="+mn-ea"/>
+        <a:cs typeface="+mn-cs"/>
+      </a:defRPr>
+    </a:lvl1pPr>
+    <a:lvl2pPr marL="457200" algn="l" defTabSz="914400" rtl="0" eaLnBrk="1" latinLnBrk="0" hangingPunct="1">
+      <a:defRPr sz="1200" kern="1200">
+        <a:solidFill>
+          <a:schemeClr val="tx1"/>
+        </a:solidFill>
+        <a:latin typeface="+mn-lt"/>
+        <a:ea typeface="+mn-ea"/>
+        <a:cs typeface="+mn-cs"/>
+      </a:defRPr>
+    </a:lvl2pPr>
+    <a:lvl3pPr marL="914400" algn="l" defTabSz="914400" rtl="0" eaLnBrk="1" latinLnBrk="0" hangingPunct="1">
+      <a:defRPr sz="1200" kern="1200">
+        <a:solidFill>
+          <a:schemeClr val="tx1"/>
+        </a:solidFill>
+        <a:latin typeface="+mn-lt"/>
+        <a:ea typeface="+mn-ea"/>
+        <a:cs typeface="+mn-cs"/>
+      </a:defRPr>
+    </a:lvl3pPr>
+    <a:lvl4pPr marL="1371600" algn="l" defTabSz="914400" rtl="0" eaLnBrk="1" latinLnBrk="0" hangingPunct="1">
+      <a:defRPr sz="1200" kern="1200">
+        <a:solidFill>
+          <a:schemeClr val="tx1"/>
+        </a:solidFill>
+        <a:latin typeface="+mn-lt"/>
+        <a:ea typeface="+mn-ea"/>
+        <a:cs typeface="+mn-cs"/>
+      </a:defRPr>
+    </a:lvl4pPr>
+    <a:lvl5pPr marL="1828800" algn="l" defTabSz="914400" rtl="0" eaLnBrk="1" latinLnBrk="0" hangingPunct="1">
+      <a:defRPr sz="1200" kern="1200">
+        <a:solidFill>
+          <a:schemeClr val="tx1"/>
+        </a:solidFill>
+        <a:latin typeface="+mn-lt"/>
+        <a:ea typeface="+mn-ea"/>
+        <a:cs typeface="+mn-cs"/>
+      </a:defRPr>
+    </a:lvl5pPr>
+    <a:lvl6pPr marL="2286000" algn="l" defTabSz="914400" rtl="0" eaLnBrk="1" latinLnBrk="0" hangingPunct="1">
+      <a:defRPr sz="1200" kern="1200">
+        <a:solidFill>
+          <a:schemeClr val="tx1"/>
+        </a:solidFill>
+        <a:latin typeface="+mn-lt"/>
+        <a:ea typeface="+mn-ea"/>
+        <a:cs typeface="+mn-cs"/>
+      </a:defRPr>
+    </a:lvl6pPr>
+    <a:lvl7pPr marL="2743200" algn="l" defTabSz="914400" rtl="0" eaLnBrk="1" latinLnBrk="0" hangingPunct="1">
+      <a:defRPr sz="1200" kern="1200">
+        <a:solidFill>
+          <a:schemeClr val="tx1"/>
+        </a:solidFill>
+        <a:latin typeface="+mn-lt"/>
+        <a:ea typeface="+mn-ea"/>
+        <a:cs typeface="+mn-cs"/>
+      </a:defRPr>
+    </a:lvl7pPr>
+    <a:lvl8pPr marL="3200400" algn="l" defTabSz="914400" rtl="0" eaLnBrk="1" latinLnBrk="0" hangingPunct="1">
+      <a:defRPr sz="1200" kern="1200">
+        <a:solidFill>
+          <a:schemeClr val="tx1"/>
+        </a:solidFill>
+        <a:latin typeface="+mn-lt"/>
+        <a:ea typeface="+mn-ea"/>
+        <a:cs typeface="+mn-cs"/>
+      </a:defRPr>
+    </a:lvl8pPr>
+    <a:lvl9pPr marL="3657600" algn="l" defTabSz="914400" rtl="0" eaLnBrk="1" latinLnBrk="0" hangingPunct="1">
+      <a:defRPr sz="1200" kern="1200">
+        <a:solidFill>
+          <a:schemeClr val="tx1"/>
+        </a:solidFill>
+        <a:latin typeface="+mn-lt"/>
+        <a:ea typeface="+mn-ea"/>
+        <a:cs typeface="+mn-cs"/>
+      </a:defRPr>
+    </a:lvl9pPr>
+  </p:notesStyle>
+</p:notesMaster>
+</file>
+
+<file path=ppt/notesSlides/notesSlide1.xml><?xml version="1.0" encoding="utf-8"?>
+<p:notes xmlns:a="http://schemas.openxmlformats.org/drawingml/2006/main" xmlns:r="http://schemas.openxmlformats.org/officeDocument/2006/relationships" xmlns:p="http://schemas.openxmlformats.org/presentationml/2006/main">
+  <p:cSld>
+    <p:spTree>
+      <p:nvGrpSpPr>
+        <p:cNvPr id="1" name=""/>
+        <p:cNvGrpSpPr/>
+        <p:nvPr/>
+      </p:nvGrpSpPr>
+      <p:grpSpPr>
+        <a:xfrm>
+          <a:off x="0" y="0"/>
+          <a:ext cx="0" cy="0"/>
+          <a:chOff x="0" y="0"/>
+          <a:chExt cx="0" cy="0"/>
+        </a:xfrm>
+      </p:grpSpPr>
+      <p:sp>
+        <p:nvSpPr>
+          <p:cNvPr id="2" name="Slide Image Placeholder 1"/>
+          <p:cNvSpPr>
+            <a:spLocks noGrp="1" noRot="1" noChangeAspect="1"/>
+          </p:cNvSpPr>
+          <p:nvPr>
+            <p:ph type="sldImg"/>
+          </p:nvPr>
+        </p:nvSpPr>
+        <p:spPr/>
+      </p:sp>
+      <p:sp>
+        <p:nvSpPr>
+          <p:cNvPr id="3" name="Notes Placeholder 2"/>
+          <p:cNvSpPr>
+            <a:spLocks noGrp="1"/>
+          </p:cNvSpPr>
+          <p:nvPr>
+            <p:ph type="body" idx="1"/>
+          </p:nvPr>
+        </p:nvSpPr>
+        <p:spPr/>
+        <p:txBody>
+          <a:bodyPr/>
+          <a:lstStyle/>
+          <a:p>
+            <a:r>
+              <a:rPr lang="en-US" dirty="0"/>
+              <a:t>Before a computer can simulate fluid passing around an obstacle inside a box (the cavity), it needs to know the laws of physics.</a:t>
+            </a:r>
+          </a:p>
+          <a:p>
+            <a:endParaRPr lang="en-US" dirty="0"/>
+          </a:p>
+          <a:p>
+            <a:r>
+              <a:rPr lang="en-US" dirty="0">
+                <a:effectLst/>
+                <a:latin typeface="Google Sans Text"/>
+              </a:rPr>
+              <a:t>Subtask 1.1 represents the </a:t>
+            </a:r>
+            <a:r>
+              <a:rPr lang="en-US" b="1" dirty="0">
+                <a:effectLst/>
+                <a:latin typeface="Google Sans Text"/>
+              </a:rPr>
+              <a:t>Mathematical Formulation</a:t>
+            </a:r>
+            <a:r>
+              <a:rPr lang="en-US" dirty="0">
+                <a:effectLst/>
+                <a:latin typeface="Google Sans Text"/>
+              </a:rPr>
+              <a:t>. In computational fluid dynamics (CFD), fluid flow is governed by the </a:t>
+            </a:r>
+            <a:r>
+              <a:rPr lang="en-US" b="1" dirty="0">
+                <a:effectLst/>
+                <a:latin typeface="Google Sans Text"/>
+              </a:rPr>
+              <a:t>Navier-Stokes equations</a:t>
+            </a:r>
+            <a:r>
+              <a:rPr lang="en-US" dirty="0">
+                <a:effectLst/>
+                <a:latin typeface="Google Sans Text"/>
+              </a:rPr>
+              <a:t> (which are basically Newton's $F=ma$ applied to liquids). To turn these complex calculus equations into something a standard computer loop can understand, they are mathematically rearranged into the </a:t>
+            </a:r>
+            <a:r>
+              <a:rPr lang="en-US" b="1" dirty="0" err="1">
+                <a:effectLst/>
+                <a:latin typeface="Google Sans Text"/>
+              </a:rPr>
+              <a:t>Streamfunction</a:t>
+            </a:r>
+            <a:r>
+              <a:rPr lang="en-US" b="1" dirty="0">
+                <a:effectLst/>
+                <a:latin typeface="Google Sans Text"/>
+              </a:rPr>
+              <a:t>-Vorticity ($\psi$-$\omega$) formulation</a:t>
+            </a:r>
+            <a:r>
+              <a:rPr lang="en-US" dirty="0">
+                <a:effectLst/>
+                <a:latin typeface="Google Sans Text"/>
+              </a:rPr>
+              <a:t>.</a:t>
+            </a:r>
+          </a:p>
+          <a:p>
+            <a:pPr>
+              <a:buFont typeface="Arial" panose="020B0604020202020204" pitchFamily="34" charset="0"/>
+              <a:buChar char="•"/>
+            </a:pPr>
+            <a:r>
+              <a:rPr lang="en-US" b="1" dirty="0">
+                <a:effectLst/>
+                <a:latin typeface="Google Sans Text"/>
+              </a:rPr>
+              <a:t>Vorticity ($\omega$):</a:t>
+            </a:r>
+            <a:r>
+              <a:rPr lang="en-US" dirty="0">
+                <a:effectLst/>
+                <a:latin typeface="Google Sans Text"/>
+              </a:rPr>
+              <a:t> Measures how much the fluid is spinning or swirling (especially around the corners of your obstacle).</a:t>
+            </a:r>
+          </a:p>
+          <a:p>
+            <a:pPr>
+              <a:buFont typeface="Arial" panose="020B0604020202020204" pitchFamily="34" charset="0"/>
+              <a:buChar char="•"/>
+            </a:pPr>
+            <a:r>
+              <a:rPr lang="en-US" b="1" dirty="0" err="1">
+                <a:effectLst/>
+                <a:latin typeface="Google Sans Text"/>
+              </a:rPr>
+              <a:t>Streamfunction</a:t>
+            </a:r>
+            <a:r>
+              <a:rPr lang="en-US" b="1" dirty="0">
+                <a:effectLst/>
+                <a:latin typeface="Google Sans Text"/>
+              </a:rPr>
+              <a:t> ($\psi$):</a:t>
+            </a:r>
+            <a:r>
+              <a:rPr lang="en-US" dirty="0">
+                <a:effectLst/>
+                <a:latin typeface="Google Sans Text"/>
+              </a:rPr>
+              <a:t> Helps track the actual path lines that particles in the fluid follow.</a:t>
+            </a:r>
+          </a:p>
+          <a:p>
+            <a:endParaRPr lang="en-US" dirty="0"/>
+          </a:p>
+          <a:p>
+            <a:r>
+              <a:rPr lang="en-US" dirty="0">
+                <a:effectLst/>
+                <a:latin typeface="Google Sans Text"/>
+              </a:rPr>
+              <a:t>Computers cannot solve fluid dynamics equations continuously. They require space to be broken down into a discrete grid of data points.</a:t>
+            </a:r>
+          </a:p>
+          <a:p>
+            <a:r>
+              <a:rPr lang="en-US" dirty="0">
+                <a:effectLst/>
+                <a:latin typeface="Google Sans Text"/>
+              </a:rPr>
+              <a:t>In Subtask 1.2, we specify the real-world sizing parameters and construct the mathematical coordinate mesh matrix ($</a:t>
+            </a:r>
+            <a:r>
+              <a:rPr lang="en-US" dirty="0" err="1">
+                <a:effectLst/>
+                <a:latin typeface="Google Sans Text"/>
+              </a:rPr>
+              <a:t>N_x</a:t>
+            </a:r>
+            <a:r>
+              <a:rPr lang="en-US" dirty="0">
+                <a:effectLst/>
+                <a:latin typeface="Google Sans Text"/>
+              </a:rPr>
+              <a:t> \times </a:t>
+            </a:r>
+            <a:r>
+              <a:rPr lang="en-US" dirty="0" err="1">
+                <a:effectLst/>
+                <a:latin typeface="Google Sans Text"/>
+              </a:rPr>
+              <a:t>N_y</a:t>
+            </a:r>
+            <a:r>
+              <a:rPr lang="en-US" dirty="0">
+                <a:effectLst/>
+                <a:latin typeface="Google Sans Text"/>
+              </a:rPr>
+              <a:t>$). Think of it as creating a digital graph-paper layout inside the box so the program knows exactly where the fluid particles are located at any given index point.</a:t>
+            </a:r>
+          </a:p>
+          <a:p>
+            <a:endParaRPr lang="en-US" dirty="0"/>
+          </a:p>
+        </p:txBody>
+      </p:sp>
+      <p:sp>
+        <p:nvSpPr>
+          <p:cNvPr id="4" name="Slide Number Placeholder 3"/>
+          <p:cNvSpPr>
+            <a:spLocks noGrp="1"/>
+          </p:cNvSpPr>
+          <p:nvPr>
+            <p:ph type="sldNum" sz="quarter" idx="5"/>
+          </p:nvPr>
+        </p:nvSpPr>
+        <p:spPr/>
+        <p:txBody>
+          <a:bodyPr/>
+          <a:lstStyle/>
+          <a:p>
+            <a:fld id="{029D3D77-4AE1-4A9F-B764-8C1063FEDE9D}" type="slidenum">
+              <a:rPr lang="en-US" smtClean="0"/>
+              <a:t>2</a:t>
+            </a:fld>
+            <a:endParaRPr lang="en-US"/>
+          </a:p>
+        </p:txBody>
+      </p:sp>
+    </p:spTree>
+    <p:extLst>
+      <p:ext uri="{BB962C8B-B14F-4D97-AF65-F5344CB8AC3E}">
+        <p14:creationId xmlns:p14="http://schemas.microsoft.com/office/powerpoint/2010/main" val="2088299687"/>
+      </p:ext>
+    </p:extLst>
+  </p:cSld>
+  <p:clrMapOvr>
+    <a:masterClrMapping/>
+  </p:clrMapOvr>
+</p:notes>
+</file>
+
+<file path=ppt/notesSlides/notesSlide2.xml><?xml version="1.0" encoding="utf-8"?>
+<p:notes xmlns:a="http://schemas.openxmlformats.org/drawingml/2006/main" xmlns:r="http://schemas.openxmlformats.org/officeDocument/2006/relationships" xmlns:p="http://schemas.openxmlformats.org/presentationml/2006/main">
+  <p:cSld>
+    <p:spTree>
+      <p:nvGrpSpPr>
+        <p:cNvPr id="1" name=""/>
+        <p:cNvGrpSpPr/>
+        <p:nvPr/>
+      </p:nvGrpSpPr>
+      <p:grpSpPr>
+        <a:xfrm>
+          <a:off x="0" y="0"/>
+          <a:ext cx="0" cy="0"/>
+          <a:chOff x="0" y="0"/>
+          <a:chExt cx="0" cy="0"/>
+        </a:xfrm>
+      </p:grpSpPr>
+      <p:sp>
+        <p:nvSpPr>
+          <p:cNvPr id="2" name="Slide Image Placeholder 1"/>
+          <p:cNvSpPr>
+            <a:spLocks noGrp="1" noRot="1" noChangeAspect="1"/>
+          </p:cNvSpPr>
+          <p:nvPr>
+            <p:ph type="sldImg"/>
+          </p:nvPr>
+        </p:nvSpPr>
+        <p:spPr/>
+      </p:sp>
+      <p:sp>
+        <p:nvSpPr>
+          <p:cNvPr id="3" name="Notes Placeholder 2"/>
+          <p:cNvSpPr>
+            <a:spLocks noGrp="1"/>
+          </p:cNvSpPr>
+          <p:nvPr>
+            <p:ph type="body" idx="1"/>
+          </p:nvPr>
+        </p:nvSpPr>
+        <p:spPr/>
+        <p:txBody>
+          <a:bodyPr/>
+          <a:lstStyle/>
+          <a:p>
+            <a:r>
+              <a:rPr lang="en-US" dirty="0"/>
+              <a:t>For fluid to swirl inside a box, something needs to drive it. In this system, the side walls and the bottom floor are completely static (zero velocity, also known as the </a:t>
+            </a:r>
+            <a:r>
+              <a:rPr lang="en-US" b="1" dirty="0"/>
+              <a:t>No-Slip boundary condition</a:t>
+            </a:r>
+            <a:r>
+              <a:rPr lang="en-US" dirty="0"/>
+              <a:t>). The top lid, however, is constantly sliding to the right at a constant forward velocity (HORIZONTAL_VELOCITY_TOP = 1.0).</a:t>
+            </a:r>
+          </a:p>
+          <a:p>
+            <a:r>
+              <a:rPr lang="en-US" dirty="0"/>
+              <a:t>Subtask 2.1 represents the code lines that explicitly pin these dynamic velocity limits on the matrix edge boundaries at every calculation tick.</a:t>
+            </a:r>
+          </a:p>
+          <a:p>
+            <a:endParaRPr lang="en-US" dirty="0"/>
+          </a:p>
+          <a:p>
+            <a:r>
+              <a:rPr lang="en-US" dirty="0"/>
+              <a:t>To introduce an obstacle inside the walls of the cavity, the code must track exactly which positions in space are fluid (where water can flow) and which are solid block (the wall).</a:t>
+            </a:r>
+          </a:p>
+          <a:p>
+            <a:r>
+              <a:rPr lang="en-US" dirty="0"/>
+              <a:t>To do this, the script creates a dedicated 2D tracking grid (solid) filled entirely with true/false Boolean conditions. Then, it calculates the raw coordinate conversions to find the exact box space matching your design parameters and overwrites those matching block dimensions to True.</a:t>
+            </a:r>
+          </a:p>
+          <a:p>
+            <a:endParaRPr lang="en-US" dirty="0"/>
+          </a:p>
+        </p:txBody>
+      </p:sp>
+      <p:sp>
+        <p:nvSpPr>
+          <p:cNvPr id="4" name="Slide Number Placeholder 3"/>
+          <p:cNvSpPr>
+            <a:spLocks noGrp="1"/>
+          </p:cNvSpPr>
+          <p:nvPr>
+            <p:ph type="sldNum" sz="quarter" idx="5"/>
+          </p:nvPr>
+        </p:nvSpPr>
+        <p:spPr/>
+        <p:txBody>
+          <a:bodyPr/>
+          <a:lstStyle/>
+          <a:p>
+            <a:fld id="{029D3D77-4AE1-4A9F-B764-8C1063FEDE9D}" type="slidenum">
+              <a:rPr lang="en-US" smtClean="0"/>
+              <a:t>3</a:t>
+            </a:fld>
+            <a:endParaRPr lang="en-US"/>
+          </a:p>
+        </p:txBody>
+      </p:sp>
+    </p:spTree>
+    <p:extLst>
+      <p:ext uri="{BB962C8B-B14F-4D97-AF65-F5344CB8AC3E}">
+        <p14:creationId xmlns:p14="http://schemas.microsoft.com/office/powerpoint/2010/main" val="4289472007"/>
+      </p:ext>
+    </p:extLst>
+  </p:cSld>
+  <p:clrMapOvr>
+    <a:masterClrMapping/>
+  </p:clrMapOvr>
+</p:notes>
+</file>
+
+<file path=ppt/notesSlides/notesSlide3.xml><?xml version="1.0" encoding="utf-8"?>
+<p:notes xmlns:a="http://schemas.openxmlformats.org/drawingml/2006/main" xmlns:r="http://schemas.openxmlformats.org/officeDocument/2006/relationships" xmlns:p="http://schemas.openxmlformats.org/presentationml/2006/main">
+  <p:cSld>
+    <p:spTree>
+      <p:nvGrpSpPr>
+        <p:cNvPr id="1" name=""/>
+        <p:cNvGrpSpPr/>
+        <p:nvPr/>
+      </p:nvGrpSpPr>
+      <p:grpSpPr>
+        <a:xfrm>
+          <a:off x="0" y="0"/>
+          <a:ext cx="0" cy="0"/>
+          <a:chOff x="0" y="0"/>
+          <a:chExt cx="0" cy="0"/>
+        </a:xfrm>
+      </p:grpSpPr>
+      <p:sp>
+        <p:nvSpPr>
+          <p:cNvPr id="2" name="Slide Image Placeholder 1"/>
+          <p:cNvSpPr>
+            <a:spLocks noGrp="1" noRot="1" noChangeAspect="1"/>
+          </p:cNvSpPr>
+          <p:nvPr>
+            <p:ph type="sldImg"/>
+          </p:nvPr>
+        </p:nvSpPr>
+        <p:spPr/>
+      </p:sp>
+      <p:sp>
+        <p:nvSpPr>
+          <p:cNvPr id="3" name="Notes Placeholder 2"/>
+          <p:cNvSpPr>
+            <a:spLocks noGrp="1"/>
+          </p:cNvSpPr>
+          <p:nvPr>
+            <p:ph type="body" idx="1"/>
+          </p:nvPr>
+        </p:nvSpPr>
+        <p:spPr/>
+        <p:txBody>
+          <a:bodyPr/>
+          <a:lstStyle/>
+          <a:p>
+            <a:r>
+              <a:rPr lang="en-US" dirty="0"/>
+              <a:t>Even though Subtask 2.2 created the </a:t>
+            </a:r>
+            <a:r>
+              <a:rPr lang="en-US" dirty="0" err="1"/>
+              <a:t>boolean</a:t>
+            </a:r>
+            <a:r>
+              <a:rPr lang="en-US" dirty="0"/>
+              <a:t> mask map (solid), the math solver doesn't inherently know that "True" means a solid block—it will still try to calculate fluid passing right through those array coordinates.</a:t>
+            </a:r>
+          </a:p>
+          <a:p>
+            <a:r>
+              <a:rPr lang="en-US" dirty="0"/>
+              <a:t>Subtask 2.3 is where you enforce the </a:t>
+            </a:r>
+            <a:r>
+              <a:rPr lang="en-US" b="1" dirty="0"/>
+              <a:t>No-Slip and Impenetrability boundary conditions</a:t>
+            </a:r>
+            <a:r>
+              <a:rPr lang="en-US" dirty="0"/>
+              <a:t> specifically for that internal obstacle. It forces the horizontal velocity (u) and vertical velocity (v) at every coordinate marked as solid to instantly overwrite to 0.0. This forces the fluid to bend, split, and flow </a:t>
+            </a:r>
+            <a:r>
+              <a:rPr lang="en-US" i="1" dirty="0"/>
+              <a:t>around</a:t>
+            </a:r>
+            <a:r>
+              <a:rPr lang="en-US" dirty="0"/>
+              <a:t> the object instead of cutting through it.</a:t>
+            </a:r>
+          </a:p>
+          <a:p>
+            <a:endParaRPr lang="en-US" dirty="0"/>
+          </a:p>
+        </p:txBody>
+      </p:sp>
+      <p:sp>
+        <p:nvSpPr>
+          <p:cNvPr id="4" name="Slide Number Placeholder 3"/>
+          <p:cNvSpPr>
+            <a:spLocks noGrp="1"/>
+          </p:cNvSpPr>
+          <p:nvPr>
+            <p:ph type="sldNum" sz="quarter" idx="5"/>
+          </p:nvPr>
+        </p:nvSpPr>
+        <p:spPr/>
+        <p:txBody>
+          <a:bodyPr/>
+          <a:lstStyle/>
+          <a:p>
+            <a:fld id="{029D3D77-4AE1-4A9F-B764-8C1063FEDE9D}" type="slidenum">
+              <a:rPr lang="en-US" smtClean="0"/>
+              <a:t>4</a:t>
+            </a:fld>
+            <a:endParaRPr lang="en-US"/>
+          </a:p>
+        </p:txBody>
+      </p:sp>
+    </p:spTree>
+    <p:extLst>
+      <p:ext uri="{BB962C8B-B14F-4D97-AF65-F5344CB8AC3E}">
+        <p14:creationId xmlns:p14="http://schemas.microsoft.com/office/powerpoint/2010/main" val="2605389351"/>
+      </p:ext>
+    </p:extLst>
+  </p:cSld>
+  <p:clrMapOvr>
+    <a:masterClrMapping/>
+  </p:clrMapOvr>
+</p:notes>
+</file>
+
+<file path=ppt/notesSlides/notesSlide4.xml><?xml version="1.0" encoding="utf-8"?>
+<p:notes xmlns:a="http://schemas.openxmlformats.org/drawingml/2006/main" xmlns:r="http://schemas.openxmlformats.org/officeDocument/2006/relationships" xmlns:p="http://schemas.openxmlformats.org/presentationml/2006/main">
+  <p:cSld>
+    <p:spTree>
+      <p:nvGrpSpPr>
+        <p:cNvPr id="1" name=""/>
+        <p:cNvGrpSpPr/>
+        <p:nvPr/>
+      </p:nvGrpSpPr>
+      <p:grpSpPr>
+        <a:xfrm>
+          <a:off x="0" y="0"/>
+          <a:ext cx="0" cy="0"/>
+          <a:chOff x="0" y="0"/>
+          <a:chExt cx="0" cy="0"/>
+        </a:xfrm>
+      </p:grpSpPr>
+      <p:sp>
+        <p:nvSpPr>
+          <p:cNvPr id="2" name="Slide Image Placeholder 1"/>
+          <p:cNvSpPr>
+            <a:spLocks noGrp="1" noRot="1" noChangeAspect="1"/>
+          </p:cNvSpPr>
+          <p:nvPr>
+            <p:ph type="sldImg"/>
+          </p:nvPr>
+        </p:nvSpPr>
+        <p:spPr/>
+      </p:sp>
+      <p:sp>
+        <p:nvSpPr>
+          <p:cNvPr id="3" name="Notes Placeholder 2"/>
+          <p:cNvSpPr>
+            <a:spLocks noGrp="1"/>
+          </p:cNvSpPr>
+          <p:nvPr>
+            <p:ph type="body" idx="1"/>
+          </p:nvPr>
+        </p:nvSpPr>
+        <p:spPr/>
+        <p:txBody>
+          <a:bodyPr/>
+          <a:lstStyle/>
+          <a:p>
+            <a:r>
+              <a:rPr lang="en-US" dirty="0">
+                <a:effectLst/>
+                <a:latin typeface="Google Sans Text"/>
+              </a:rPr>
+              <a:t>In a </a:t>
+            </a:r>
+            <a:r>
+              <a:rPr lang="en-US" dirty="0" err="1">
+                <a:effectLst/>
+                <a:latin typeface="Google Sans Text"/>
+              </a:rPr>
+              <a:t>Streamfunction</a:t>
+            </a:r>
+            <a:r>
+              <a:rPr lang="en-US" dirty="0">
+                <a:effectLst/>
+                <a:latin typeface="Google Sans Text"/>
+              </a:rPr>
+              <a:t>-Vorticity fluid scheme, fluid flow changes over time because of two physical forces acting on the vorticity ($\omega$):</a:t>
+            </a:r>
+          </a:p>
+          <a:p>
+            <a:pPr>
+              <a:buFont typeface="+mj-lt"/>
+              <a:buAutoNum type="arabicPeriod"/>
+            </a:pPr>
+            <a:r>
+              <a:rPr lang="en-US" b="1" dirty="0">
+                <a:effectLst/>
+                <a:latin typeface="Google Sans Text"/>
+              </a:rPr>
+              <a:t>Advection:</a:t>
+            </a:r>
+            <a:r>
+              <a:rPr lang="en-US" dirty="0">
+                <a:effectLst/>
+                <a:latin typeface="Google Sans Text"/>
+              </a:rPr>
+              <a:t> The fluid's own velocity vectors (u and v) physically push and drag the rotational swirl profiles sideways across the grid points.</a:t>
+            </a:r>
+          </a:p>
+          <a:p>
+            <a:pPr>
+              <a:buFont typeface="+mj-lt"/>
+              <a:buAutoNum type="arabicPeriod"/>
+            </a:pPr>
+            <a:r>
+              <a:rPr lang="en-US" b="1" dirty="0">
+                <a:effectLst/>
+                <a:latin typeface="Google Sans Text"/>
+              </a:rPr>
+              <a:t>Diffusion:</a:t>
+            </a:r>
+            <a:r>
+              <a:rPr lang="en-US" dirty="0">
+                <a:effectLst/>
+                <a:latin typeface="Google Sans Text"/>
+              </a:rPr>
+              <a:t> The internal molecular friction of the liquid (the fluid thickness, mapped by KINEMATIC_VISCOSITY) naturally smooths out sharp velocity differences over time.</a:t>
+            </a:r>
+          </a:p>
+          <a:p>
+            <a:r>
+              <a:rPr lang="en-US" dirty="0">
+                <a:effectLst/>
+                <a:latin typeface="Google Sans Text"/>
+              </a:rPr>
+              <a:t>Subtask 3.1 utilizes the mathematical spatial gradients built in 1.1 to move the fluid grid forward by a tiny fraction of time (TIME_STEP_LENGTH).</a:t>
+            </a:r>
+          </a:p>
+          <a:p>
+            <a:endParaRPr lang="en-US" dirty="0"/>
+          </a:p>
+          <a:p>
+            <a:r>
+              <a:rPr lang="en-US" dirty="0">
+                <a:effectLst/>
+                <a:latin typeface="Google Sans Text"/>
+              </a:rPr>
+              <a:t>Once Subtask 3.1 calculates how much the fluid is swirling around at the new time step, the model must figure out how the physical speed maps onto streamline curves ($\psi$). Mathematically, this requires solving an elliptic differential rule known as the </a:t>
+            </a:r>
+            <a:r>
+              <a:rPr lang="en-US" b="1" dirty="0">
+                <a:effectLst/>
+                <a:latin typeface="Google Sans Text"/>
+              </a:rPr>
+              <a:t>Poisson equation</a:t>
+            </a:r>
+            <a:r>
+              <a:rPr lang="en-US" dirty="0">
+                <a:effectLst/>
+                <a:latin typeface="Google Sans Text"/>
+              </a:rPr>
+              <a:t> ($\nabla^2\psi = -\omega$).</a:t>
+            </a:r>
+          </a:p>
+          <a:p>
+            <a:r>
+              <a:rPr lang="en-US" dirty="0">
+                <a:effectLst/>
+                <a:latin typeface="Google Sans Text"/>
+              </a:rPr>
+              <a:t>Because computers cannot resolve these multi-directional dependency grids instantly, you use a </a:t>
+            </a:r>
+            <a:r>
+              <a:rPr lang="en-US" b="1" dirty="0">
+                <a:effectLst/>
+                <a:latin typeface="Google Sans Text"/>
+              </a:rPr>
+              <a:t>relaxation scheme</a:t>
+            </a:r>
+            <a:r>
+              <a:rPr lang="en-US" dirty="0">
+                <a:effectLst/>
+                <a:latin typeface="Google Sans Text"/>
+              </a:rPr>
+              <a:t>. The code takes the previous state as a starting point, guesses the new balance values, evaluates the errors against neighbor arrays, and repeats this update process 50 times per step to "relax" into a stable stream field.</a:t>
+            </a:r>
+          </a:p>
+          <a:p>
+            <a:endParaRPr lang="en-US" dirty="0"/>
+          </a:p>
+          <a:p>
+            <a:r>
+              <a:rPr lang="en-US" dirty="0"/>
+              <a:t>When you solve fluid dynamics equations iteratively, you need a way to verify that your answers are actually approaching a correct physical state rather than exploding into random numbers (a common issue in fluid codes).</a:t>
+            </a:r>
+          </a:p>
+          <a:p>
+            <a:r>
+              <a:rPr lang="en-US" dirty="0"/>
+              <a:t>Subtask 3.3 is about tracking </a:t>
+            </a:r>
+            <a:r>
+              <a:rPr lang="en-US" b="1" dirty="0"/>
+              <a:t>residuals</a:t>
+            </a:r>
+            <a:r>
+              <a:rPr lang="en-US" dirty="0"/>
+              <a:t>—which are the calculated differences between the current fluid state and the previous step's fluid state. By storing these errors in a list and plotting them on a logarithmic scale, you prove to your instructor that the system stabilized (converged) and reached a valid steady-state solution.</a:t>
+            </a:r>
+          </a:p>
+          <a:p>
+            <a:endParaRPr lang="en-US" dirty="0"/>
+          </a:p>
+        </p:txBody>
+      </p:sp>
+      <p:sp>
+        <p:nvSpPr>
+          <p:cNvPr id="4" name="Slide Number Placeholder 3"/>
+          <p:cNvSpPr>
+            <a:spLocks noGrp="1"/>
+          </p:cNvSpPr>
+          <p:nvPr>
+            <p:ph type="sldNum" sz="quarter" idx="5"/>
+          </p:nvPr>
+        </p:nvSpPr>
+        <p:spPr/>
+        <p:txBody>
+          <a:bodyPr/>
+          <a:lstStyle/>
+          <a:p>
+            <a:fld id="{029D3D77-4AE1-4A9F-B764-8C1063FEDE9D}" type="slidenum">
+              <a:rPr lang="en-US" smtClean="0"/>
+              <a:t>5</a:t>
+            </a:fld>
+            <a:endParaRPr lang="en-US"/>
+          </a:p>
+        </p:txBody>
+      </p:sp>
+    </p:spTree>
+    <p:extLst>
+      <p:ext uri="{BB962C8B-B14F-4D97-AF65-F5344CB8AC3E}">
+        <p14:creationId xmlns:p14="http://schemas.microsoft.com/office/powerpoint/2010/main" val="2096455012"/>
+      </p:ext>
+    </p:extLst>
+  </p:cSld>
+  <p:clrMapOvr>
+    <a:masterClrMapping/>
+  </p:clrMapOvr>
+</p:notes>
+</file>
+
+<file path=ppt/notesSlides/notesSlide5.xml><?xml version="1.0" encoding="utf-8"?>
+<p:notes xmlns:a="http://schemas.openxmlformats.org/drawingml/2006/main" xmlns:r="http://schemas.openxmlformats.org/officeDocument/2006/relationships" xmlns:p="http://schemas.openxmlformats.org/presentationml/2006/main">
+  <p:cSld>
+    <p:spTree>
+      <p:nvGrpSpPr>
+        <p:cNvPr id="1" name=""/>
+        <p:cNvGrpSpPr/>
+        <p:nvPr/>
+      </p:nvGrpSpPr>
+      <p:grpSpPr>
+        <a:xfrm>
+          <a:off x="0" y="0"/>
+          <a:ext cx="0" cy="0"/>
+          <a:chOff x="0" y="0"/>
+          <a:chExt cx="0" cy="0"/>
+        </a:xfrm>
+      </p:grpSpPr>
+      <p:sp>
+        <p:nvSpPr>
+          <p:cNvPr id="2" name="Slide Image Placeholder 1"/>
+          <p:cNvSpPr>
+            <a:spLocks noGrp="1" noRot="1" noChangeAspect="1"/>
+          </p:cNvSpPr>
+          <p:nvPr>
+            <p:ph type="sldImg"/>
+          </p:nvPr>
+        </p:nvSpPr>
+        <p:spPr/>
+      </p:sp>
+      <p:sp>
+        <p:nvSpPr>
+          <p:cNvPr id="3" name="Notes Placeholder 2"/>
+          <p:cNvSpPr>
+            <a:spLocks noGrp="1"/>
+          </p:cNvSpPr>
+          <p:nvPr>
+            <p:ph type="body" idx="1"/>
+          </p:nvPr>
+        </p:nvSpPr>
+        <p:spPr/>
+        <p:txBody>
+          <a:bodyPr/>
+          <a:lstStyle/>
+          <a:p>
+            <a:r>
+              <a:rPr lang="en-US" dirty="0">
+                <a:effectLst/>
+                <a:latin typeface="Google Sans Text"/>
+              </a:rPr>
+              <a:t>Up until this point, the solver loop has just been crunching a bunch of numbers in separate matrix grids (a 2D matrix for horizontal speeds $u$, and a 2D matrix for vertical speeds $v$).</a:t>
+            </a:r>
+          </a:p>
+          <a:p>
+            <a:r>
+              <a:rPr lang="en-US" dirty="0">
+                <a:effectLst/>
+                <a:latin typeface="Google Sans Text"/>
+              </a:rPr>
+              <a:t>Subtask 4.1 is where you </a:t>
+            </a:r>
+            <a:r>
+              <a:rPr lang="en-US" b="1" dirty="0">
+                <a:effectLst/>
+                <a:latin typeface="Google Sans Text"/>
+              </a:rPr>
+              <a:t>extract</a:t>
+            </a:r>
+            <a:r>
+              <a:rPr lang="en-US" dirty="0">
+                <a:effectLst/>
+                <a:latin typeface="Google Sans Text"/>
+              </a:rPr>
+              <a:t> those independent speed arrays, combine them to find the true overall magnitude (speed) at any given coordinate, apply your obstacle mask so lines don't get drawn inside the solid box, and use a numerical tracer algorithm (</a:t>
+            </a:r>
+            <a:r>
+              <a:rPr lang="en-US" dirty="0" err="1">
+                <a:effectLst/>
+                <a:latin typeface="Google Sans Text"/>
+              </a:rPr>
+              <a:t>plt.streamplot</a:t>
+            </a:r>
+            <a:r>
+              <a:rPr lang="en-US" dirty="0">
+                <a:effectLst/>
+                <a:latin typeface="Google Sans Text"/>
+              </a:rPr>
+              <a:t>) to trace continuous fluid pathways (streamlines) around the obstacle.</a:t>
+            </a:r>
+          </a:p>
+          <a:p>
+            <a:endParaRPr lang="en-US" dirty="0"/>
+          </a:p>
+          <a:p>
+            <a:r>
+              <a:rPr lang="en-US" dirty="0"/>
+              <a:t>Before throwing an animation onto a screen, a computational physics model needs a configured canvas wrapper. Subtask 4.2 focuses on generating a high-fidelity snapshot setup that visualizes magnitude distributions (like velocity speed or pressure variations) across the spatial geometry.</a:t>
+            </a:r>
+          </a:p>
+          <a:p>
+            <a:r>
+              <a:rPr lang="en-US" dirty="0"/>
+              <a:t>By applying an image mapping function (</a:t>
+            </a:r>
+            <a:r>
+              <a:rPr lang="en-US" dirty="0" err="1"/>
+              <a:t>imshow</a:t>
+            </a:r>
+            <a:r>
+              <a:rPr lang="en-US" dirty="0"/>
+              <a:t>) along with a customized bounding box shape (</a:t>
+            </a:r>
+            <a:r>
+              <a:rPr lang="en-US" dirty="0" err="1"/>
+              <a:t>patches.Rectangle</a:t>
+            </a:r>
+            <a:r>
+              <a:rPr lang="en-US" dirty="0"/>
+              <a:t>), this step creates a standardized backdrop where a color gradient scale map (from slow blue to rapid red) visually isolates the physical placement and impact of the central obstacle.</a:t>
+            </a:r>
+          </a:p>
+          <a:p>
+            <a:endParaRPr lang="en-US" dirty="0"/>
+          </a:p>
+        </p:txBody>
+      </p:sp>
+      <p:sp>
+        <p:nvSpPr>
+          <p:cNvPr id="4" name="Slide Number Placeholder 3"/>
+          <p:cNvSpPr>
+            <a:spLocks noGrp="1"/>
+          </p:cNvSpPr>
+          <p:nvPr>
+            <p:ph type="sldNum" sz="quarter" idx="5"/>
+          </p:nvPr>
+        </p:nvSpPr>
+        <p:spPr/>
+        <p:txBody>
+          <a:bodyPr/>
+          <a:lstStyle/>
+          <a:p>
+            <a:fld id="{029D3D77-4AE1-4A9F-B764-8C1063FEDE9D}" type="slidenum">
+              <a:rPr lang="en-US" smtClean="0"/>
+              <a:t>6</a:t>
+            </a:fld>
+            <a:endParaRPr lang="en-US"/>
+          </a:p>
+        </p:txBody>
+      </p:sp>
+    </p:spTree>
+    <p:extLst>
+      <p:ext uri="{BB962C8B-B14F-4D97-AF65-F5344CB8AC3E}">
+        <p14:creationId xmlns:p14="http://schemas.microsoft.com/office/powerpoint/2010/main" val="1975536084"/>
+      </p:ext>
+    </p:extLst>
+  </p:cSld>
+  <p:clrMapOvr>
+    <a:masterClrMapping/>
+  </p:clrMapOvr>
+</p:notes>
+</file>
+
+<file path=ppt/notesSlides/notesSlide6.xml><?xml version="1.0" encoding="utf-8"?>
+<p:notes xmlns:a="http://schemas.openxmlformats.org/drawingml/2006/main" xmlns:r="http://schemas.openxmlformats.org/officeDocument/2006/relationships" xmlns:p="http://schemas.openxmlformats.org/presentationml/2006/main">
+  <p:cSld>
+    <p:spTree>
+      <p:nvGrpSpPr>
+        <p:cNvPr id="1" name=""/>
+        <p:cNvGrpSpPr/>
+        <p:nvPr/>
+      </p:nvGrpSpPr>
+      <p:grpSpPr>
+        <a:xfrm>
+          <a:off x="0" y="0"/>
+          <a:ext cx="0" cy="0"/>
+          <a:chOff x="0" y="0"/>
+          <a:chExt cx="0" cy="0"/>
+        </a:xfrm>
+      </p:grpSpPr>
+      <p:sp>
+        <p:nvSpPr>
+          <p:cNvPr id="2" name="Slide Image Placeholder 1"/>
+          <p:cNvSpPr>
+            <a:spLocks noGrp="1" noRot="1" noChangeAspect="1"/>
+          </p:cNvSpPr>
+          <p:nvPr>
+            <p:ph type="sldImg"/>
+          </p:nvPr>
+        </p:nvSpPr>
+        <p:spPr/>
+      </p:sp>
+      <p:sp>
+        <p:nvSpPr>
+          <p:cNvPr id="3" name="Notes Placeholder 2"/>
+          <p:cNvSpPr>
+            <a:spLocks noGrp="1"/>
+          </p:cNvSpPr>
+          <p:nvPr>
+            <p:ph type="body" idx="1"/>
+          </p:nvPr>
+        </p:nvSpPr>
+        <p:spPr/>
+        <p:txBody>
+          <a:bodyPr/>
+          <a:lstStyle/>
+          <a:p>
+            <a:r>
+              <a:rPr lang="en-US" dirty="0"/>
+              <a:t>A static picture only shows fluid patterns at one fixed point in time (like the final steady state). However, fluid physics are deeply temporal: when the top lid suddenly starts sliding, waves and vortices slowly crop up, warp around the obstacle, and change shape before settling down.</a:t>
+            </a:r>
+          </a:p>
+          <a:p>
+            <a:r>
+              <a:rPr lang="en-US" dirty="0"/>
+              <a:t>Subtask 4.3 is about taking your historic frames list variable, building an automated update engine (def update(</a:t>
+            </a:r>
+            <a:r>
+              <a:rPr lang="en-US" dirty="0" err="1"/>
+              <a:t>i</a:t>
+            </a:r>
+            <a:r>
+              <a:rPr lang="en-US" dirty="0"/>
+              <a:t>):), and passing it into a compiler that automatically strings those individual array snapshots into an interactive web-based animation movie (HTML(</a:t>
+            </a:r>
+            <a:r>
+              <a:rPr lang="en-US" dirty="0" err="1"/>
+              <a:t>ani.to_jshtml</a:t>
+            </a:r>
+            <a:r>
+              <a:rPr lang="en-US" dirty="0"/>
+              <a:t>())).</a:t>
+            </a:r>
+          </a:p>
+          <a:p>
+            <a:endParaRPr lang="en-US" dirty="0"/>
+          </a:p>
+        </p:txBody>
+      </p:sp>
+      <p:sp>
+        <p:nvSpPr>
+          <p:cNvPr id="4" name="Slide Number Placeholder 3"/>
+          <p:cNvSpPr>
+            <a:spLocks noGrp="1"/>
+          </p:cNvSpPr>
+          <p:nvPr>
+            <p:ph type="sldNum" sz="quarter" idx="5"/>
+          </p:nvPr>
+        </p:nvSpPr>
+        <p:spPr/>
+        <p:txBody>
+          <a:bodyPr/>
+          <a:lstStyle/>
+          <a:p>
+            <a:fld id="{029D3D77-4AE1-4A9F-B764-8C1063FEDE9D}" type="slidenum">
+              <a:rPr lang="en-US" smtClean="0"/>
+              <a:t>7</a:t>
+            </a:fld>
+            <a:endParaRPr lang="en-US"/>
+          </a:p>
+        </p:txBody>
+      </p:sp>
+    </p:spTree>
+    <p:extLst>
+      <p:ext uri="{BB962C8B-B14F-4D97-AF65-F5344CB8AC3E}">
+        <p14:creationId xmlns:p14="http://schemas.microsoft.com/office/powerpoint/2010/main" val="131009037"/>
+      </p:ext>
+    </p:extLst>
+  </p:cSld>
+  <p:clrMapOvr>
+    <a:masterClrMapping/>
+  </p:clrMapOvr>
+</p:notes>
+</file>
+
 <file path=ppt/slideLayouts/slideLayout1.xml><?xml version="1.0" encoding="utf-8"?>
 <p:sldLayout xmlns:a="http://schemas.openxmlformats.org/drawingml/2006/main" xmlns:r="http://schemas.openxmlformats.org/officeDocument/2006/relationships" xmlns:p="http://schemas.openxmlformats.org/presentationml/2006/main" type="title" preserve="1">
   <p:cSld name="Title Slide">
@@ -304,7 +1643,7 @@
           <a:p>
             <a:fld id="{ADD862A3-4AE1-478D-9E0B-FFA75BF76DFC}" type="datetimeFigureOut">
               <a:rPr lang="en-US" smtClean="0"/>
-              <a:t>5/19/2026</a:t>
+              <a:t>5/21/2026</a:t>
             </a:fld>
             <a:endParaRPr lang="en-US"/>
           </a:p>
@@ -579,7 +1918,7 @@
           <a:p>
             <a:fld id="{ADD862A3-4AE1-478D-9E0B-FFA75BF76DFC}" type="datetimeFigureOut">
               <a:rPr lang="en-US" smtClean="0"/>
-              <a:t>5/19/2026</a:t>
+              <a:t>5/21/2026</a:t>
             </a:fld>
             <a:endParaRPr lang="en-US"/>
           </a:p>
@@ -773,7 +2112,7 @@
           <a:p>
             <a:fld id="{ADD862A3-4AE1-478D-9E0B-FFA75BF76DFC}" type="datetimeFigureOut">
               <a:rPr lang="en-US" smtClean="0"/>
-              <a:t>5/19/2026</a:t>
+              <a:t>5/21/2026</a:t>
             </a:fld>
             <a:endParaRPr lang="en-US"/>
           </a:p>
@@ -1046,7 +2385,7 @@
           <a:p>
             <a:fld id="{ADD862A3-4AE1-478D-9E0B-FFA75BF76DFC}" type="datetimeFigureOut">
               <a:rPr lang="en-US" smtClean="0"/>
-              <a:t>5/19/2026</a:t>
+              <a:t>5/21/2026</a:t>
             </a:fld>
             <a:endParaRPr lang="en-US"/>
           </a:p>
@@ -1387,7 +2726,7 @@
           <a:p>
             <a:fld id="{ADD862A3-4AE1-478D-9E0B-FFA75BF76DFC}" type="datetimeFigureOut">
               <a:rPr lang="en-US" smtClean="0"/>
-              <a:t>5/19/2026</a:t>
+              <a:t>5/21/2026</a:t>
             </a:fld>
             <a:endParaRPr lang="en-US"/>
           </a:p>
@@ -2010,7 +3349,7 @@
           <a:p>
             <a:fld id="{ADD862A3-4AE1-478D-9E0B-FFA75BF76DFC}" type="datetimeFigureOut">
               <a:rPr lang="en-US" smtClean="0"/>
-              <a:t>5/19/2026</a:t>
+              <a:t>5/21/2026</a:t>
             </a:fld>
             <a:endParaRPr lang="en-US"/>
           </a:p>
@@ -2870,7 +4209,7 @@
           <a:p>
             <a:fld id="{ADD862A3-4AE1-478D-9E0B-FFA75BF76DFC}" type="datetimeFigureOut">
               <a:rPr lang="en-US" smtClean="0"/>
-              <a:t>5/19/2026</a:t>
+              <a:t>5/21/2026</a:t>
             </a:fld>
             <a:endParaRPr lang="en-US"/>
           </a:p>
@@ -3040,7 +4379,7 @@
           <a:p>
             <a:fld id="{ADD862A3-4AE1-478D-9E0B-FFA75BF76DFC}" type="datetimeFigureOut">
               <a:rPr lang="en-US" smtClean="0"/>
-              <a:t>5/19/2026</a:t>
+              <a:t>5/21/2026</a:t>
             </a:fld>
             <a:endParaRPr lang="en-US"/>
           </a:p>
@@ -3220,7 +4559,7 @@
           <a:p>
             <a:fld id="{ADD862A3-4AE1-478D-9E0B-FFA75BF76DFC}" type="datetimeFigureOut">
               <a:rPr lang="en-US" smtClean="0"/>
-              <a:t>5/19/2026</a:t>
+              <a:t>5/21/2026</a:t>
             </a:fld>
             <a:endParaRPr lang="en-US"/>
           </a:p>
@@ -3390,7 +4729,7 @@
           <a:p>
             <a:fld id="{ADD862A3-4AE1-478D-9E0B-FFA75BF76DFC}" type="datetimeFigureOut">
               <a:rPr lang="en-US" smtClean="0"/>
-              <a:t>5/19/2026</a:t>
+              <a:t>5/21/2026</a:t>
             </a:fld>
             <a:endParaRPr lang="en-US"/>
           </a:p>
@@ -3637,7 +4976,7 @@
           <a:p>
             <a:fld id="{ADD862A3-4AE1-478D-9E0B-FFA75BF76DFC}" type="datetimeFigureOut">
               <a:rPr lang="en-US" smtClean="0"/>
-              <a:t>5/19/2026</a:t>
+              <a:t>5/21/2026</a:t>
             </a:fld>
             <a:endParaRPr lang="en-US"/>
           </a:p>
@@ -3929,7 +5268,7 @@
           <a:p>
             <a:fld id="{ADD862A3-4AE1-478D-9E0B-FFA75BF76DFC}" type="datetimeFigureOut">
               <a:rPr lang="en-US" smtClean="0"/>
-              <a:t>5/19/2026</a:t>
+              <a:t>5/21/2026</a:t>
             </a:fld>
             <a:endParaRPr lang="en-US"/>
           </a:p>
@@ -4373,7 +5712,7 @@
           <a:p>
             <a:fld id="{ADD862A3-4AE1-478D-9E0B-FFA75BF76DFC}" type="datetimeFigureOut">
               <a:rPr lang="en-US" smtClean="0"/>
-              <a:t>5/19/2026</a:t>
+              <a:t>5/21/2026</a:t>
             </a:fld>
             <a:endParaRPr lang="en-US"/>
           </a:p>
@@ -4491,7 +5830,7 @@
           <a:p>
             <a:fld id="{ADD862A3-4AE1-478D-9E0B-FFA75BF76DFC}" type="datetimeFigureOut">
               <a:rPr lang="en-US" smtClean="0"/>
-              <a:t>5/19/2026</a:t>
+              <a:t>5/21/2026</a:t>
             </a:fld>
             <a:endParaRPr lang="en-US"/>
           </a:p>
@@ -4586,7 +5925,7 @@
           <a:p>
             <a:fld id="{ADD862A3-4AE1-478D-9E0B-FFA75BF76DFC}" type="datetimeFigureOut">
               <a:rPr lang="en-US" smtClean="0"/>
-              <a:t>5/19/2026</a:t>
+              <a:t>5/21/2026</a:t>
             </a:fld>
             <a:endParaRPr lang="en-US"/>
           </a:p>
@@ -4865,7 +6204,7 @@
           <a:p>
             <a:fld id="{ADD862A3-4AE1-478D-9E0B-FFA75BF76DFC}" type="datetimeFigureOut">
               <a:rPr lang="en-US" smtClean="0"/>
-              <a:t>5/19/2026</a:t>
+              <a:t>5/21/2026</a:t>
             </a:fld>
             <a:endParaRPr lang="en-US"/>
           </a:p>
@@ -5140,7 +6479,7 @@
           <a:p>
             <a:fld id="{ADD862A3-4AE1-478D-9E0B-FFA75BF76DFC}" type="datetimeFigureOut">
               <a:rPr lang="en-US" smtClean="0"/>
-              <a:t>5/19/2026</a:t>
+              <a:t>5/21/2026</a:t>
             </a:fld>
             <a:endParaRPr lang="en-US"/>
           </a:p>
@@ -5569,7 +6908,7 @@
           <a:p>
             <a:fld id="{ADD862A3-4AE1-478D-9E0B-FFA75BF76DFC}" type="datetimeFigureOut">
               <a:rPr lang="en-US" smtClean="0"/>
-              <a:t>5/19/2026</a:t>
+              <a:t>5/21/2026</a:t>
             </a:fld>
             <a:endParaRPr lang="en-US"/>
           </a:p>
@@ -6124,7 +7463,7 @@
                   <a:schemeClr val="accent3"/>
                 </a:solidFill>
               </a:rPr>
-              <a:t>Lid-driven Cavity</a:t>
+              <a:t>Lid-driven Cavity with obstacle</a:t>
             </a:r>
             <a:r>
               <a:rPr lang="en-US" dirty="0"/>
@@ -6269,8 +7608,8 @@
           </a:p>
         </p:txBody>
       </p:sp>
-      <mc:AlternateContent xmlns:mc="http://schemas.openxmlformats.org/markup-compatibility/2006">
-        <mc:Choice xmlns:a14="http://schemas.microsoft.com/office/drawing/2010/main" Requires="a14">
+      <mc:AlternateContent xmlns:mc="http://schemas.openxmlformats.org/markup-compatibility/2006" xmlns:a14="http://schemas.microsoft.com/office/drawing/2010/main">
+        <mc:Choice Requires="a14">
           <p:sp>
             <p:nvSpPr>
               <p:cNvPr id="3" name="Content Placeholder 2">
@@ -6407,7 +7746,7 @@
             </p:txBody>
           </p:sp>
         </mc:Choice>
-        <mc:Fallback>
+        <mc:Fallback xmlns="">
           <p:sp>
             <p:nvSpPr>
               <p:cNvPr id="3" name="Content Placeholder 2">
@@ -6430,7 +7769,7 @@
                 <a:ext cx="6394768" cy="4195481"/>
               </a:xfrm>
               <a:blipFill>
-                <a:blip r:embed="rId2"/>
+                <a:blip r:embed="rId3"/>
                 <a:stretch>
                   <a:fillRect l="-477" t="-1599" b="-2035"/>
                 </a:stretch>
@@ -6466,7 +7805,7 @@
           <p:nvPr/>
         </p:nvPicPr>
         <p:blipFill>
-          <a:blip r:embed="rId3"/>
+          <a:blip r:embed="rId4"/>
           <a:stretch>
             <a:fillRect/>
           </a:stretch>
@@ -6481,8 +7820,8 @@
           </a:prstGeom>
         </p:spPr>
       </p:pic>
-      <mc:AlternateContent xmlns:mc="http://schemas.openxmlformats.org/markup-compatibility/2006">
-        <mc:Choice xmlns:a14="http://schemas.microsoft.com/office/drawing/2010/main" Requires="a14">
+      <mc:AlternateContent xmlns:mc="http://schemas.openxmlformats.org/markup-compatibility/2006" xmlns:a14="http://schemas.microsoft.com/office/drawing/2010/main">
+        <mc:Choice Requires="a14">
           <p:sp>
             <p:nvSpPr>
               <p:cNvPr id="5" name="TextBox 4">
@@ -6789,7 +8128,7 @@
             </p:txBody>
           </p:sp>
         </mc:Choice>
-        <mc:Fallback>
+        <mc:Fallback xmlns="">
           <p:sp>
             <p:nvSpPr>
               <p:cNvPr id="5" name="TextBox 4">
@@ -6813,7 +8152,7 @@
                 <a:avLst/>
               </a:prstGeom>
               <a:blipFill>
-                <a:blip r:embed="rId4"/>
+                <a:blip r:embed="rId5"/>
                 <a:stretch>
                   <a:fillRect/>
                 </a:stretch>
@@ -6849,7 +8188,7 @@
           <p:nvPr/>
         </p:nvPicPr>
         <p:blipFill>
-          <a:blip r:embed="rId5"/>
+          <a:blip r:embed="rId6"/>
           <a:stretch>
             <a:fillRect/>
           </a:stretch>
@@ -6864,8 +8203,8 @@
           </a:prstGeom>
         </p:spPr>
       </p:pic>
-      <mc:AlternateContent xmlns:mc="http://schemas.openxmlformats.org/markup-compatibility/2006">
-        <mc:Choice xmlns:a14="http://schemas.microsoft.com/office/drawing/2010/main" Requires="a14">
+      <mc:AlternateContent xmlns:mc="http://schemas.openxmlformats.org/markup-compatibility/2006" xmlns:a14="http://schemas.microsoft.com/office/drawing/2010/main">
+        <mc:Choice Requires="a14">
           <p:sp>
             <p:nvSpPr>
               <p:cNvPr id="10" name="TextBox 9">
@@ -6936,7 +8275,7 @@
             </p:txBody>
           </p:sp>
         </mc:Choice>
-        <mc:Fallback>
+        <mc:Fallback xmlns="">
           <p:sp>
             <p:nvSpPr>
               <p:cNvPr id="10" name="TextBox 9">
@@ -6960,7 +8299,7 @@
                 <a:avLst/>
               </a:prstGeom>
               <a:blipFill>
-                <a:blip r:embed="rId6"/>
+                <a:blip r:embed="rId7"/>
                 <a:stretch>
                   <a:fillRect/>
                 </a:stretch>
@@ -6996,7 +8335,7 @@
           <p:nvPr/>
         </p:nvPicPr>
         <p:blipFill>
-          <a:blip r:embed="rId7"/>
+          <a:blip r:embed="rId8"/>
           <a:stretch>
             <a:fillRect/>
           </a:stretch>
@@ -7161,7 +8500,7 @@
           <p:nvPr/>
         </p:nvPicPr>
         <p:blipFill>
-          <a:blip r:embed="rId2"/>
+          <a:blip r:embed="rId3"/>
           <a:stretch>
             <a:fillRect/>
           </a:stretch>
@@ -7191,7 +8530,7 @@
           <p:nvPr/>
         </p:nvPicPr>
         <p:blipFill>
-          <a:blip r:embed="rId3"/>
+          <a:blip r:embed="rId4"/>
           <a:stretch>
             <a:fillRect/>
           </a:stretch>
@@ -7334,7 +8673,7 @@
           <p:nvPr/>
         </p:nvPicPr>
         <p:blipFill>
-          <a:blip r:embed="rId2"/>
+          <a:blip r:embed="rId3"/>
           <a:stretch>
             <a:fillRect/>
           </a:stretch>
@@ -7552,7 +8891,7 @@
           <p:nvPr/>
         </p:nvPicPr>
         <p:blipFill>
-          <a:blip r:embed="rId2"/>
+          <a:blip r:embed="rId3"/>
           <a:stretch>
             <a:fillRect/>
           </a:stretch>
@@ -7582,7 +8921,7 @@
           <p:nvPr/>
         </p:nvPicPr>
         <p:blipFill>
-          <a:blip r:embed="rId3"/>
+          <a:blip r:embed="rId4"/>
           <a:stretch>
             <a:fillRect/>
           </a:stretch>
@@ -7612,7 +8951,7 @@
           <p:nvPr/>
         </p:nvPicPr>
         <p:blipFill>
-          <a:blip r:embed="rId4"/>
+          <a:blip r:embed="rId5"/>
           <a:stretch>
             <a:fillRect/>
           </a:stretch>
@@ -7642,7 +8981,7 @@
           <p:nvPr/>
         </p:nvPicPr>
         <p:blipFill>
-          <a:blip r:embed="rId5"/>
+          <a:blip r:embed="rId6"/>
           <a:stretch>
             <a:fillRect/>
           </a:stretch>
@@ -7806,7 +9145,7 @@
           <p:nvPr/>
         </p:nvPicPr>
         <p:blipFill>
-          <a:blip r:embed="rId2"/>
+          <a:blip r:embed="rId3"/>
           <a:stretch>
             <a:fillRect/>
           </a:stretch>
@@ -7836,7 +9175,7 @@
           <p:nvPr/>
         </p:nvPicPr>
         <p:blipFill>
-          <a:blip r:embed="rId3"/>
+          <a:blip r:embed="rId4"/>
           <a:stretch>
             <a:fillRect/>
           </a:stretch>
@@ -7976,7 +9315,7 @@
           <p:nvPr/>
         </p:nvPicPr>
         <p:blipFill>
-          <a:blip r:embed="rId2"/>
+          <a:blip r:embed="rId3"/>
           <a:stretch>
             <a:fillRect/>
           </a:stretch>
@@ -8268,4 +9607,299 @@
     </a:ext>
   </a:extLst>
 </a:theme>
+</file>
+
+<file path=ppt/theme/theme2.xml><?xml version="1.0" encoding="utf-8"?>
+<a:theme xmlns:a="http://schemas.openxmlformats.org/drawingml/2006/main" name="Office Theme">
+  <a:themeElements>
+    <a:clrScheme name="Office">
+      <a:dk1>
+        <a:sysClr val="windowText" lastClr="000000"/>
+      </a:dk1>
+      <a:lt1>
+        <a:sysClr val="window" lastClr="FFFFFF"/>
+      </a:lt1>
+      <a:dk2>
+        <a:srgbClr val="44546A"/>
+      </a:dk2>
+      <a:lt2>
+        <a:srgbClr val="E7E6E6"/>
+      </a:lt2>
+      <a:accent1>
+        <a:srgbClr val="4472C4"/>
+      </a:accent1>
+      <a:accent2>
+        <a:srgbClr val="ED7D31"/>
+      </a:accent2>
+      <a:accent3>
+        <a:srgbClr val="A5A5A5"/>
+      </a:accent3>
+      <a:accent4>
+        <a:srgbClr val="FFC000"/>
+      </a:accent4>
+      <a:accent5>
+        <a:srgbClr val="5B9BD5"/>
+      </a:accent5>
+      <a:accent6>
+        <a:srgbClr val="70AD47"/>
+      </a:accent6>
+      <a:hlink>
+        <a:srgbClr val="0563C1"/>
+      </a:hlink>
+      <a:folHlink>
+        <a:srgbClr val="954F72"/>
+      </a:folHlink>
+    </a:clrScheme>
+    <a:fontScheme name="Office">
+      <a:majorFont>
+        <a:latin typeface="Calibri Light" panose="020F0302020204030204"/>
+        <a:ea typeface=""/>
+        <a:cs typeface=""/>
+        <a:font script="Jpan" typeface="游ゴシック Light"/>
+        <a:font script="Hang" typeface="맑은 고딕"/>
+        <a:font script="Hans" typeface="等线 Light"/>
+        <a:font script="Hant" typeface="新細明體"/>
+        <a:font script="Arab" typeface="Times New Roman"/>
+        <a:font script="Hebr" typeface="Times New Roman"/>
+        <a:font script="Thai" typeface="Angsana New"/>
+        <a:font script="Ethi" typeface="Nyala"/>
+        <a:font script="Beng" typeface="Vrinda"/>
+        <a:font script="Gujr" typeface="Shruti"/>
+        <a:font script="Khmr" typeface="MoolBoran"/>
+        <a:font script="Knda" typeface="Tunga"/>
+        <a:font script="Guru" typeface="Raavi"/>
+        <a:font script="Cans" typeface="Euphemia"/>
+        <a:font script="Cher" typeface="Plantagenet Cherokee"/>
+        <a:font script="Yiii" typeface="Microsoft Yi Baiti"/>
+        <a:font script="Tibt" typeface="Microsoft Himalaya"/>
+        <a:font script="Thaa" typeface="MV Boli"/>
+        <a:font script="Deva" typeface="Mangal"/>
+        <a:font script="Telu" typeface="Gautami"/>
+        <a:font script="Taml" typeface="Latha"/>
+        <a:font script="Syrc" typeface="Estrangelo Edessa"/>
+        <a:font script="Orya" typeface="Kalinga"/>
+        <a:font script="Mlym" typeface="Kartika"/>
+        <a:font script="Laoo" typeface="DokChampa"/>
+        <a:font script="Sinh" typeface="Iskoola Pota"/>
+        <a:font script="Mong" typeface="Mongolian Baiti"/>
+        <a:font script="Viet" typeface="Times New Roman"/>
+        <a:font script="Uigh" typeface="Microsoft Uighur"/>
+        <a:font script="Geor" typeface="Sylfaen"/>
+        <a:font script="Armn" typeface="Arial"/>
+        <a:font script="Bugi" typeface="Leelawadee UI"/>
+        <a:font script="Bopo" typeface="Microsoft JhengHei"/>
+        <a:font script="Java" typeface="Javanese Text"/>
+        <a:font script="Lisu" typeface="Segoe UI"/>
+        <a:font script="Mymr" typeface="Myanmar Text"/>
+        <a:font script="Nkoo" typeface="Ebrima"/>
+        <a:font script="Olck" typeface="Nirmala UI"/>
+        <a:font script="Osma" typeface="Ebrima"/>
+        <a:font script="Phag" typeface="Phagspa"/>
+        <a:font script="Syrn" typeface="Estrangelo Edessa"/>
+        <a:font script="Syrj" typeface="Estrangelo Edessa"/>
+        <a:font script="Syre" typeface="Estrangelo Edessa"/>
+        <a:font script="Sora" typeface="Nirmala UI"/>
+        <a:font script="Tale" typeface="Microsoft Tai Le"/>
+        <a:font script="Talu" typeface="Microsoft New Tai Lue"/>
+        <a:font script="Tfng" typeface="Ebrima"/>
+      </a:majorFont>
+      <a:minorFont>
+        <a:latin typeface="Calibri" panose="020F0502020204030204"/>
+        <a:ea typeface=""/>
+        <a:cs typeface=""/>
+        <a:font script="Jpan" typeface="游ゴシック"/>
+        <a:font script="Hang" typeface="맑은 고딕"/>
+        <a:font script="Hans" typeface="等线"/>
+        <a:font script="Hant" typeface="新細明體"/>
+        <a:font script="Arab" typeface="Arial"/>
+        <a:font script="Hebr" typeface="Arial"/>
+        <a:font script="Thai" typeface="Cordia New"/>
+        <a:font script="Ethi" typeface="Nyala"/>
+        <a:font script="Beng" typeface="Vrinda"/>
+        <a:font script="Gujr" typeface="Shruti"/>
+        <a:font script="Khmr" typeface="DaunPenh"/>
+        <a:font script="Knda" typeface="Tunga"/>
+        <a:font script="Guru" typeface="Raavi"/>
+        <a:font script="Cans" typeface="Euphemia"/>
+        <a:font script="Cher" typeface="Plantagenet Cherokee"/>
+        <a:font script="Yiii" typeface="Microsoft Yi Baiti"/>
+        <a:font script="Tibt" typeface="Microsoft Himalaya"/>
+        <a:font script="Thaa" typeface="MV Boli"/>
+        <a:font script="Deva" typeface="Mangal"/>
+        <a:font script="Telu" typeface="Gautami"/>
+        <a:font script="Taml" typeface="Latha"/>
+        <a:font script="Syrc" typeface="Estrangelo Edessa"/>
+        <a:font script="Orya" typeface="Kalinga"/>
+        <a:font script="Mlym" typeface="Kartika"/>
+        <a:font script="Laoo" typeface="DokChampa"/>
+        <a:font script="Sinh" typeface="Iskoola Pota"/>
+        <a:font script="Mong" typeface="Mongolian Baiti"/>
+        <a:font script="Viet" typeface="Arial"/>
+        <a:font script="Uigh" typeface="Microsoft Uighur"/>
+        <a:font script="Geor" typeface="Sylfaen"/>
+        <a:font script="Armn" typeface="Arial"/>
+        <a:font script="Bugi" typeface="Leelawadee UI"/>
+        <a:font script="Bopo" typeface="Microsoft JhengHei"/>
+        <a:font script="Java" typeface="Javanese Text"/>
+        <a:font script="Lisu" typeface="Segoe UI"/>
+        <a:font script="Mymr" typeface="Myanmar Text"/>
+        <a:font script="Nkoo" typeface="Ebrima"/>
+        <a:font script="Olck" typeface="Nirmala UI"/>
+        <a:font script="Osma" typeface="Ebrima"/>
+        <a:font script="Phag" typeface="Phagspa"/>
+        <a:font script="Syrn" typeface="Estrangelo Edessa"/>
+        <a:font script="Syrj" typeface="Estrangelo Edessa"/>
+        <a:font script="Syre" typeface="Estrangelo Edessa"/>
+        <a:font script="Sora" typeface="Nirmala UI"/>
+        <a:font script="Tale" typeface="Microsoft Tai Le"/>
+        <a:font script="Talu" typeface="Microsoft New Tai Lue"/>
+        <a:font script="Tfng" typeface="Ebrima"/>
+      </a:minorFont>
+    </a:fontScheme>
+    <a:fmtScheme name="Office">
+      <a:fillStyleLst>
+        <a:solidFill>
+          <a:schemeClr val="phClr"/>
+        </a:solidFill>
+        <a:gradFill rotWithShape="1">
+          <a:gsLst>
+            <a:gs pos="0">
+              <a:schemeClr val="phClr">
+                <a:lumMod val="110000"/>
+                <a:satMod val="105000"/>
+                <a:tint val="67000"/>
+              </a:schemeClr>
+            </a:gs>
+            <a:gs pos="50000">
+              <a:schemeClr val="phClr">
+                <a:lumMod val="105000"/>
+                <a:satMod val="103000"/>
+                <a:tint val="73000"/>
+              </a:schemeClr>
+            </a:gs>
+            <a:gs pos="100000">
+              <a:schemeClr val="phClr">
+                <a:lumMod val="105000"/>
+                <a:satMod val="109000"/>
+                <a:tint val="81000"/>
+              </a:schemeClr>
+            </a:gs>
+          </a:gsLst>
+          <a:lin ang="5400000" scaled="0"/>
+        </a:gradFill>
+        <a:gradFill rotWithShape="1">
+          <a:gsLst>
+            <a:gs pos="0">
+              <a:schemeClr val="phClr">
+                <a:satMod val="103000"/>
+                <a:lumMod val="102000"/>
+                <a:tint val="94000"/>
+              </a:schemeClr>
+            </a:gs>
+            <a:gs pos="50000">
+              <a:schemeClr val="phClr">
+                <a:satMod val="110000"/>
+                <a:lumMod val="100000"/>
+                <a:shade val="100000"/>
+              </a:schemeClr>
+            </a:gs>
+            <a:gs pos="100000">
+              <a:schemeClr val="phClr">
+                <a:lumMod val="99000"/>
+                <a:satMod val="120000"/>
+                <a:shade val="78000"/>
+              </a:schemeClr>
+            </a:gs>
+          </a:gsLst>
+          <a:lin ang="5400000" scaled="0"/>
+        </a:gradFill>
+      </a:fillStyleLst>
+      <a:lnStyleLst>
+        <a:ln w="6350" cap="flat" cmpd="sng" algn="ctr">
+          <a:solidFill>
+            <a:schemeClr val="phClr"/>
+          </a:solidFill>
+          <a:prstDash val="solid"/>
+          <a:miter lim="800000"/>
+        </a:ln>
+        <a:ln w="12700" cap="flat" cmpd="sng" algn="ctr">
+          <a:solidFill>
+            <a:schemeClr val="phClr"/>
+          </a:solidFill>
+          <a:prstDash val="solid"/>
+          <a:miter lim="800000"/>
+        </a:ln>
+        <a:ln w="19050" cap="flat" cmpd="sng" algn="ctr">
+          <a:solidFill>
+            <a:schemeClr val="phClr"/>
+          </a:solidFill>
+          <a:prstDash val="solid"/>
+          <a:miter lim="800000"/>
+        </a:ln>
+      </a:lnStyleLst>
+      <a:effectStyleLst>
+        <a:effectStyle>
+          <a:effectLst/>
+        </a:effectStyle>
+        <a:effectStyle>
+          <a:effectLst/>
+        </a:effectStyle>
+        <a:effectStyle>
+          <a:effectLst>
+            <a:outerShdw blurRad="57150" dist="19050" dir="5400000" algn="ctr" rotWithShape="0">
+              <a:srgbClr val="000000">
+                <a:alpha val="63000"/>
+              </a:srgbClr>
+            </a:outerShdw>
+          </a:effectLst>
+        </a:effectStyle>
+      </a:effectStyleLst>
+      <a:bgFillStyleLst>
+        <a:solidFill>
+          <a:schemeClr val="phClr"/>
+        </a:solidFill>
+        <a:solidFill>
+          <a:schemeClr val="phClr">
+            <a:tint val="95000"/>
+            <a:satMod val="170000"/>
+          </a:schemeClr>
+        </a:solidFill>
+        <a:gradFill rotWithShape="1">
+          <a:gsLst>
+            <a:gs pos="0">
+              <a:schemeClr val="phClr">
+                <a:tint val="93000"/>
+                <a:satMod val="150000"/>
+                <a:shade val="98000"/>
+                <a:lumMod val="102000"/>
+              </a:schemeClr>
+            </a:gs>
+            <a:gs pos="50000">
+              <a:schemeClr val="phClr">
+                <a:tint val="98000"/>
+                <a:satMod val="130000"/>
+                <a:shade val="90000"/>
+                <a:lumMod val="103000"/>
+              </a:schemeClr>
+            </a:gs>
+            <a:gs pos="100000">
+              <a:schemeClr val="phClr">
+                <a:shade val="63000"/>
+                <a:satMod val="120000"/>
+              </a:schemeClr>
+            </a:gs>
+          </a:gsLst>
+          <a:lin ang="5400000" scaled="0"/>
+        </a:gradFill>
+      </a:bgFillStyleLst>
+    </a:fmtScheme>
+  </a:themeElements>
+  <a:objectDefaults/>
+  <a:extraClrSchemeLst/>
+  <a:extLst>
+    <a:ext uri="{05A4C25C-085E-4340-85A3-A5531E510DB2}">
+      <thm15:themeFamily xmlns:thm15="http://schemas.microsoft.com/office/thememl/2012/main" name="Office Theme" id="{62F939B6-93AF-4DB8-9C6B-D6C7DFDC589F}" vid="{4A3C46E8-61CC-4603-A589-7422A47A8E4A}"/>
+    </a:ext>
+  </a:extLst>
+</a:theme>
 </file>
</xml_diff>